<commit_message>
The pictures still said UDP: the deployed Zenoh link is TCP
Since ADR-0006's 2026-09-23 amendment every node dials tcp/<router>:7448 --
udp ?rel=1 cannot relay on this zenoh build and waits for a fix there; QUIC
on :7449 is opt-in. The hero image, three diagrams, two slides, the facts
file and running-an-experiment.md still described Reliable UDP on :7447 as
the link, and the guide drew conclusions from it ("no congestion control, so
loss does not throttle the sender") that are the opposite of TCP's.

All now say TCP :7448, QUIC opt-in, and udp ?rel=1 listened but unused,
awaiting the Zenoh fix. _facts.yml splits the router into its three
listeners. The doc-sync skill's hero spec had the N6 port as tcp:7447 and is
corrected. Every changed visual was re-rendered and looked at; the two
dataflow PNGs also carry the single-font fix from three commits back.
</commit_message>
<xml_diff>
--- a/docs/slides/mec-cast-architecture.pptx
+++ b/docs/slides/mec-cast-architecture.pptx
@@ -5519,7 +5519,7 @@
                 <a:ea typeface="Calibri" pitchFamily="34" charset="-122"/>
                 <a:cs typeface="Calibri" pitchFamily="34" charset="-120"/>
               </a:rPr>
-              <a:t>port 7447</a:t>
+              <a:t>tcp :7448</a:t>
             </a:r>
             <a:endParaRPr lang="en-US" sz="1050" dirty="0"/>
           </a:p>
@@ -11109,7 +11109,7 @@
                 <a:ea typeface="Calibri" pitchFamily="34" charset="-122"/>
                 <a:cs typeface="Calibri" pitchFamily="34" charset="-120"/>
               </a:rPr>
-              <a:t>large payloads over lossy links; here udp/7447?rel=1 —</a:t>
+              <a:t>large payloads over lossy links; here tcp/7448,</a:t>
             </a:r>
             <a:endParaRPr lang="en-US" sz="1050" dirty="0"/>
           </a:p>
@@ -11129,7 +11129,7 @@
                 <a:ea typeface="Calibri" pitchFamily="34" charset="-122"/>
                 <a:cs typeface="Calibri" pitchFamily="34" charset="-120"/>
               </a:rPr>
-              <a:t>retransmit, no congestion control, no TLS</a:t>
+              <a:t>QUIC opt-in; udp ?rel=1 awaits a Zenoh fix</a:t>
             </a:r>
             <a:endParaRPr lang="en-US" sz="1050" dirty="0"/>
           </a:p>

</xml_diff>

<commit_message>
The diagrams, deck and hero image still drew Zenoh as the only middleware
- Overview and lab diagrams (and their README fences): the edge's centre is
  the Zenoh router or the Fast DDS Discovery Server, with its ports.
- Runtime topology: the MIDDLEWARE env, both centres by compose profile,
  and DDS's direct data path to the edge. Lifecycle: both RMWs.
- Deck slide 7 becomes "Middleware — Zenoh or Fast DDS"; slides 1, 2, 3, 5
  and 11 drop their Zenoh-only lines.
- Hero: client, edge and N6 labels and the footer name both middlewares.
</commit_message>
<xml_diff>
--- a/docs/slides/mec-cast-architecture.pptx
+++ b/docs/slides/mec-cast-architecture.pptx
@@ -2235,7 +2235,7 @@
                 <a:ea typeface="Calibri" pitchFamily="34" charset="-122"/>
                 <a:cs typeface="Calibri" pitchFamily="34" charset="-120"/>
               </a:rPr>
-              <a:t>Zenoh ingest node</a:t>
+              <a:t>ROS2 ingest node</a:t>
             </a:r>
             <a:endParaRPr lang="en-US" sz="1050" dirty="0"/>
           </a:p>
@@ -4803,7 +4803,7 @@
                 <a:ea typeface="Calibri" pitchFamily="34" charset="-122"/>
                 <a:cs typeface="Calibri" pitchFamily="34" charset="-120"/>
               </a:rPr>
-              <a:t>Zenoh versus DDS over the same 5G link</a:t>
+              <a:t>Campaign: Zenoh versus Fast DDS over 5G</a:t>
             </a:r>
             <a:endParaRPr lang="en-US" sz="1100" dirty="0"/>
           </a:p>
@@ -5457,7 +5457,7 @@
                 <a:ea typeface="Calibri" pitchFamily="34" charset="-122"/>
                 <a:cs typeface="Calibri" pitchFamily="34" charset="-120"/>
               </a:rPr>
-              <a:t>zenoh-router</a:t>
+              <a:t>middleware centre</a:t>
             </a:r>
             <a:endParaRPr lang="en-US" sz="1300" dirty="0"/>
           </a:p>
@@ -5499,7 +5499,7 @@
                 <a:ea typeface="Calibri" pitchFamily="34" charset="-122"/>
                 <a:cs typeface="Calibri" pitchFamily="34" charset="-120"/>
               </a:rPr>
-              <a:t>the rendezvous point</a:t>
+              <a:t>zenoh-router or dds-discovery</a:t>
             </a:r>
             <a:endParaRPr lang="en-US" sz="1050" dirty="0"/>
           </a:p>
@@ -5519,7 +5519,7 @@
                 <a:ea typeface="Calibri" pitchFamily="34" charset="-122"/>
                 <a:cs typeface="Calibri" pitchFamily="34" charset="-120"/>
               </a:rPr>
-              <a:t>tcp :7448</a:t>
+              <a:t>MIDDLEWARE picks one</a:t>
             </a:r>
             <a:endParaRPr lang="en-US" sz="1050" dirty="0"/>
           </a:p>
@@ -5992,6 +5992,26 @@
                 <a:cs typeface="Calibri" pitchFamily="34" charset="-120"/>
               </a:rPr>
               <a:t>make up-local</a:t>
+            </a:r>
+            <a:endParaRPr lang="en-US" sz="1150" dirty="0"/>
+          </a:p>
+          <a:p>
+            <a:pPr indent="0" marL="0">
+              <a:lnSpc>
+                <a:spcPct val="115000"/>
+              </a:lnSpc>
+              <a:buNone/>
+            </a:pPr>
+            <a:r>
+              <a:rPr lang="en-US" sz="1150" dirty="0">
+                <a:solidFill>
+                  <a:srgbClr val="444C52"/>
+                </a:solidFill>
+                <a:latin typeface="Calibri" pitchFamily="34" charset="0"/>
+                <a:ea typeface="Calibri" pitchFamily="34" charset="-122"/>
+                <a:cs typeface="Calibri" pitchFamily="34" charset="-120"/>
+              </a:rPr>
+              <a:t>MIDDLEWARE=dds make up-local</a:t>
             </a:r>
             <a:endParaRPr lang="en-US" sz="1150" dirty="0"/>
           </a:p>
@@ -6401,7 +6421,7 @@
                 <a:ea typeface="Calibri" pitchFamily="34" charset="-122"/>
                 <a:cs typeface="Calibri" pitchFamily="34" charset="-120"/>
               </a:rPr>
-              <a:t>needs EDGE_HOST</a:t>
+              <a:t>EDGE_HOST, MIDDLEWARE</a:t>
             </a:r>
             <a:endParaRPr lang="en-US" sz="1050" dirty="0"/>
           </a:p>
@@ -6653,7 +6673,7 @@
                 <a:ea typeface="Calibri" pitchFamily="34" charset="-122"/>
                 <a:cs typeface="Calibri" pitchFamily="34" charset="-120"/>
               </a:rPr>
-              <a:t>zenoh-router + edge</a:t>
+              <a:t>router or DDS server + edge</a:t>
             </a:r>
             <a:endParaRPr lang="en-US" sz="1050" dirty="0"/>
           </a:p>
@@ -9042,7 +9062,7 @@
                 <a:ea typeface="Calibri" pitchFamily="34" charset="-122"/>
                 <a:cs typeface="Calibri" pitchFamily="34" charset="-120"/>
               </a:rPr>
-              <a:t>The timing envelope rides in-band as a message field, because rmw_zenoh does not expose per-publish attachments to the application layer.</a:t>
+              <a:t>The timing envelope rides in-band as a message field, because rclpy exposes no per-publish attachments on either middleware.</a:t>
             </a:r>
             <a:endParaRPr lang="en-US" sz="1150" dirty="0"/>
           </a:p>
@@ -10185,7 +10205,7 @@
                 <a:ea typeface="Cambria" pitchFamily="34" charset="-122"/>
                 <a:cs typeface="Cambria" pitchFamily="34" charset="-120"/>
               </a:rPr>
-              <a:t>Zenoh communication layer</a:t>
+              <a:t>Middleware — Zenoh or Fast DDS</a:t>
             </a:r>
             <a:endParaRPr lang="en-US" sz="3200" dirty="0"/>
           </a:p>
@@ -10224,7 +10244,7 @@
                 <a:ea typeface="Calibri" pitchFamily="34" charset="-122"/>
                 <a:cs typeface="Calibri" pitchFamily="34" charset="-120"/>
               </a:rPr>
-              <a:t>rmw_zenoh rather than raw DDS. The application stays vanilla ROS2; only the middleware swaps.</a:t>
+              <a:t>Chosen at deployment, the same on every host. The application stays vanilla ROS2; only the RMW swaps.</a:t>
             </a:r>
             <a:endParaRPr lang="en-US" sz="1300" dirty="0"/>
           </a:p>
@@ -10288,7 +10308,7 @@
                 <a:ea typeface="Calibri" pitchFamily="34" charset="-122"/>
                 <a:cs typeface="Calibri" pitchFamily="34" charset="-120"/>
               </a:rPr>
-              <a:t>UE session</a:t>
+              <a:t>UE nodes</a:t>
             </a:r>
             <a:endParaRPr lang="en-US" sz="1300" dirty="0"/>
           </a:p>
@@ -10330,7 +10350,7 @@
                 <a:ea typeface="Calibri" pitchFamily="34" charset="-122"/>
                 <a:cs typeface="Calibri" pitchFamily="34" charset="-120"/>
               </a:rPr>
-              <a:t>dials out to the router</a:t>
+              <a:t>dial OUT to the edge host</a:t>
             </a:r>
             <a:endParaRPr lang="en-US" sz="1050" dirty="0"/>
           </a:p>
@@ -10394,7 +10414,7 @@
                 <a:ea typeface="Calibri" pitchFamily="34" charset="-122"/>
                 <a:cs typeface="Calibri" pitchFamily="34" charset="-120"/>
               </a:rPr>
-              <a:t>zenoh router (edge host)</a:t>
+              <a:t>centre on the edge host</a:t>
             </a:r>
             <a:endParaRPr lang="en-US" sz="1300" dirty="0"/>
           </a:p>
@@ -10436,7 +10456,27 @@
                 <a:ea typeface="Calibri" pitchFamily="34" charset="-122"/>
                 <a:cs typeface="Calibri" pitchFamily="34" charset="-120"/>
               </a:rPr>
-              <a:t>unicast rendezvous — no multicast anywhere</a:t>
+              <a:t>Zenoh router, or Fast DDS Discovery Server</a:t>
+            </a:r>
+            <a:endParaRPr lang="en-US" sz="1050" dirty="0"/>
+          </a:p>
+          <a:p>
+            <a:pPr indent="0" marL="0">
+              <a:lnSpc>
+                <a:spcPct val="108000"/>
+              </a:lnSpc>
+              <a:buNone/>
+            </a:pPr>
+            <a:r>
+              <a:rPr lang="en-US" sz="1050" dirty="0">
+                <a:solidFill>
+                  <a:srgbClr val="444C52"/>
+                </a:solidFill>
+                <a:latin typeface="Calibri" pitchFamily="34" charset="0"/>
+                <a:ea typeface="Calibri" pitchFamily="34" charset="-122"/>
+                <a:cs typeface="Calibri" pitchFamily="34" charset="-120"/>
+              </a:rPr>
+              <a:t>unicast only — no multicast anywhere</a:t>
             </a:r>
             <a:endParaRPr lang="en-US" sz="1050" dirty="0"/>
           </a:p>
@@ -10500,7 +10540,7 @@
                 <a:ea typeface="Calibri" pitchFamily="34" charset="-122"/>
                 <a:cs typeface="Calibri" pitchFamily="34" charset="-120"/>
               </a:rPr>
-              <a:t>edge session</a:t>
+              <a:t>edge node</a:t>
             </a:r>
             <a:endParaRPr lang="en-US" sz="1300" dirty="0"/>
           </a:p>
@@ -10542,7 +10582,7 @@
                 <a:ea typeface="Calibri" pitchFamily="34" charset="-122"/>
                 <a:cs typeface="Calibri" pitchFamily="34" charset="-120"/>
               </a:rPr>
-              <a:t>subscribes via the router</a:t>
+              <a:t>subscribes; same topics, same QoS</a:t>
             </a:r>
             <a:endParaRPr lang="en-US" sz="1050" dirty="0"/>
           </a:p>
@@ -10705,7 +10745,7 @@
                 <a:ea typeface="Calibri" pitchFamily="34" charset="-122"/>
                 <a:cs typeface="Calibri" pitchFamily="34" charset="-120"/>
               </a:rPr>
-              <a:t>Discovery across NAT / UPF</a:t>
+              <a:t>Links</a:t>
             </a:r>
             <a:endParaRPr lang="en-US" sz="1100" dirty="0"/>
           </a:p>
@@ -10716,6 +10756,17 @@
               </a:lnSpc>
               <a:buNone/>
             </a:pPr>
+            <a:r>
+              <a:rPr lang="en-US" sz="1100" dirty="0">
+                <a:solidFill>
+                  <a:srgbClr val="444C52"/>
+                </a:solidFill>
+                <a:latin typeface="Calibri" pitchFamily="34" charset="0"/>
+                <a:ea typeface="Calibri" pitchFamily="34" charset="-122"/>
+                <a:cs typeface="Calibri" pitchFamily="34" charset="-120"/>
+              </a:rPr>
+              <a:t>Discovery across the UPF</a:t>
+            </a:r>
             <a:endParaRPr lang="en-US" sz="1100" dirty="0"/>
           </a:p>
           <a:p>
@@ -10734,7 +10785,7 @@
                 <a:ea typeface="Calibri" pitchFamily="34" charset="-122"/>
                 <a:cs typeface="Calibri" pitchFamily="34" charset="-120"/>
               </a:rPr>
-              <a:t>Data-path NAT traversal</a:t>
+              <a:t>Data path</a:t>
             </a:r>
             <a:endParaRPr lang="en-US" sz="1100" dirty="0"/>
           </a:p>
@@ -10745,6 +10796,17 @@
               </a:lnSpc>
               <a:buNone/>
             </a:pPr>
+            <a:r>
+              <a:rPr lang="en-US" sz="1100" dirty="0">
+                <a:solidFill>
+                  <a:srgbClr val="444C52"/>
+                </a:solidFill>
+                <a:latin typeface="Calibri" pitchFamily="34" charset="0"/>
+                <a:ea typeface="Calibri" pitchFamily="34" charset="-122"/>
+                <a:cs typeface="Calibri" pitchFamily="34" charset="-120"/>
+              </a:rPr>
+              <a:t>A NAT at the UPF</a:t>
+            </a:r>
             <a:endParaRPr lang="en-US" sz="1100" dirty="0"/>
           </a:p>
           <a:p>
@@ -10763,7 +10825,7 @@
                 <a:ea typeface="Calibri" pitchFamily="34" charset="-122"/>
                 <a:cs typeface="Calibri" pitchFamily="34" charset="-120"/>
               </a:rPr>
-              <a:t>Large samples (~2 MB)</a:t>
+              <a:t>Staying on the 5G link</a:t>
             </a:r>
             <a:endParaRPr lang="en-US" sz="1100" dirty="0"/>
           </a:p>
@@ -10827,7 +10889,7 @@
                 <a:ea typeface="Calibri" pitchFamily="34" charset="-122"/>
                 <a:cs typeface="Calibri" pitchFamily="34" charset="-120"/>
               </a:rPr>
-              <a:t>DDS</a:t>
+              <a:t>Zenoh — MIDDLEWARE=zenoh</a:t>
             </a:r>
             <a:endParaRPr lang="en-US" sz="1300" dirty="0"/>
           </a:p>
@@ -10878,7 +10940,7 @@
                 <a:ea typeface="Calibri" pitchFamily="34" charset="-122"/>
                 <a:cs typeface="Calibri" pitchFamily="34" charset="-120"/>
               </a:rPr>
-              <a:t>SPDP is multicast — the cellular user plane drops it</a:t>
+              <a:t>tcp :7448 (default) · quic :7449</a:t>
             </a:r>
             <a:endParaRPr lang="en-US" sz="1050" dirty="0"/>
           </a:p>
@@ -10889,6 +10951,17 @@
               </a:lnSpc>
               <a:buNone/>
             </a:pPr>
+            <a:r>
+              <a:rPr lang="en-US" sz="1050" dirty="0">
+                <a:solidFill>
+                  <a:srgbClr val="444C52"/>
+                </a:solidFill>
+                <a:latin typeface="Calibri" pitchFamily="34" charset="0"/>
+                <a:ea typeface="Calibri" pitchFamily="34" charset="-122"/>
+                <a:cs typeface="Calibri" pitchFamily="34" charset="-120"/>
+              </a:rPr>
+              <a:t>clients of the router</a:t>
+            </a:r>
             <a:endParaRPr lang="en-US" sz="1050" dirty="0"/>
           </a:p>
           <a:p>
@@ -10907,7 +10980,7 @@
                 <a:ea typeface="Calibri" pitchFamily="34" charset="-122"/>
                 <a:cs typeface="Calibri" pitchFamily="34" charset="-120"/>
               </a:rPr>
-              <a:t>announces private-IP locators the peer cannot reach</a:t>
+              <a:t>the router relays every sample</a:t>
             </a:r>
             <a:endParaRPr lang="en-US" sz="1050" dirty="0"/>
           </a:p>
@@ -10918,6 +10991,17 @@
               </a:lnSpc>
               <a:buNone/>
             </a:pPr>
+            <a:r>
+              <a:rPr lang="en-US" sz="1050" dirty="0">
+                <a:solidFill>
+                  <a:srgbClr val="444C52"/>
+                </a:solidFill>
+                <a:latin typeface="Calibri" pitchFamily="34" charset="0"/>
+                <a:ea typeface="Calibri" pitchFamily="34" charset="-122"/>
+                <a:cs typeface="Calibri" pitchFamily="34" charset="-120"/>
+              </a:rPr>
+              <a:t>traversed: the UE dials out</a:t>
+            </a:r>
             <a:endParaRPr lang="en-US" sz="1050" dirty="0"/>
           </a:p>
           <a:p>
@@ -10936,7 +11020,7 @@
                 <a:ea typeface="Calibri" pitchFamily="34" charset="-122"/>
                 <a:cs typeface="Calibri" pitchFamily="34" charset="-120"/>
               </a:rPr>
-              <a:t>RTPS fragments; one lost fragment loses the sample</a:t>
+              <a:t>a client dials one address</a:t>
             </a:r>
             <a:endParaRPr lang="en-US" sz="1050" dirty="0"/>
           </a:p>
@@ -11000,7 +11084,7 @@
                 <a:ea typeface="Calibri" pitchFamily="34" charset="-122"/>
                 <a:cs typeface="Calibri" pitchFamily="34" charset="-120"/>
               </a:rPr>
-              <a:t>Zenoh</a:t>
+              <a:t>Fast DDS — MIDDLEWARE=dds</a:t>
             </a:r>
             <a:endParaRPr lang="en-US" sz="1300" dirty="0"/>
           </a:p>
@@ -11051,7 +11135,7 @@
                 <a:ea typeface="Calibri" pitchFamily="34" charset="-122"/>
                 <a:cs typeface="Calibri" pitchFamily="34" charset="-120"/>
               </a:rPr>
-              <a:t>router-based unicast dial-out, traverses NAT natively</a:t>
+              <a:t>udp (default) · tcp</a:t>
             </a:r>
             <a:endParaRPr lang="en-US" sz="1050" dirty="0"/>
           </a:p>
@@ -11062,6 +11146,17 @@
               </a:lnSpc>
               <a:buNone/>
             </a:pPr>
+            <a:r>
+              <a:rPr lang="en-US" sz="1050" dirty="0">
+                <a:solidFill>
+                  <a:srgbClr val="444C52"/>
+                </a:solidFill>
+                <a:latin typeface="Calibri" pitchFamily="34" charset="0"/>
+                <a:ea typeface="Calibri" pitchFamily="34" charset="-122"/>
+                <a:cs typeface="Calibri" pitchFamily="34" charset="-120"/>
+              </a:rPr>
+              <a:t>Discovery Server :11811, never SPDP</a:t>
+            </a:r>
             <a:endParaRPr lang="en-US" sz="1050" dirty="0"/>
           </a:p>
           <a:p>
@@ -11080,7 +11175,7 @@
                 <a:ea typeface="Calibri" pitchFamily="34" charset="-122"/>
                 <a:cs typeface="Calibri" pitchFamily="34" charset="-120"/>
               </a:rPr>
-              <a:t>the UE dials out — an outbound connection just works</a:t>
+              <a:t>peer to peer RTPS, udp 7400+ or tcp :7410</a:t>
             </a:r>
             <a:endParaRPr lang="en-US" sz="1050" dirty="0"/>
           </a:p>
@@ -11091,6 +11186,17 @@
               </a:lnSpc>
               <a:buNone/>
             </a:pPr>
+            <a:r>
+              <a:rPr lang="en-US" sz="1050" dirty="0">
+                <a:solidFill>
+                  <a:srgbClr val="444C52"/>
+                </a:solidFill>
+                <a:latin typeface="Calibri" pitchFamily="34" charset="0"/>
+                <a:ea typeface="Calibri" pitchFamily="34" charset="-122"/>
+                <a:cs typeface="Calibri" pitchFamily="34" charset="-120"/>
+              </a:rPr>
+              <a:t>udp needs a routable UE; tcp dials out</a:t>
+            </a:r>
             <a:endParaRPr lang="en-US" sz="1050" dirty="0"/>
           </a:p>
           <a:p>
@@ -11109,27 +11215,7 @@
                 <a:ea typeface="Calibri" pitchFamily="34" charset="-122"/>
                 <a:cs typeface="Calibri" pitchFamily="34" charset="-120"/>
               </a:rPr>
-              <a:t>large payloads over lossy links; here tcp/7448,</a:t>
-            </a:r>
-            <a:endParaRPr lang="en-US" sz="1050" dirty="0"/>
-          </a:p>
-          <a:p>
-            <a:pPr indent="0" marL="0">
-              <a:lnSpc>
-                <a:spcPct val="108000"/>
-              </a:lnSpc>
-              <a:buNone/>
-            </a:pPr>
-            <a:r>
-              <a:rPr lang="en-US" sz="1050" dirty="0">
-                <a:solidFill>
-                  <a:srgbClr val="444C52"/>
-                </a:solidFill>
-                <a:latin typeface="Calibri" pitchFamily="34" charset="0"/>
-                <a:ea typeface="Calibri" pitchFamily="34" charset="-122"/>
-                <a:cs typeface="Calibri" pitchFamily="34" charset="-120"/>
-              </a:rPr>
-              <a:t>QUIC opt-in; udp ?rel=1 awaits a Zenoh fix</a:t>
+              <a:t>DDS_INTERFACES pins the interfaces</a:t>
             </a:r>
             <a:endParaRPr lang="en-US" sz="1050" dirty="0"/>
           </a:p>
@@ -11171,7 +11257,7 @@
                 <a:ea typeface="Calibri" pitchFamily="34" charset="-122"/>
                 <a:cs typeface="Calibri" pitchFamily="34" charset="-120"/>
               </a:rPr>
-              <a:t>DDS is the more popular and more mature industrial standard — but that popularity is measured on local networks, and this path is NAT'd, lossy and uplink-constrained. Because the edge subscriber depends only on the telemetry crate, "Zenoh versus DDS over 5G" remains a measurable result rather than a closed door.</a:t>
+              <a:t>One knob per deployment (ADR-0013). The image's entrypoint configures the RMW; the nodes never name one. Each node reports what it runs, the admin shows it per zone and flags a mix, and run.json records it — so Zenoh versus DDS over 5G is a recorded factor of every run, not a rebuild.</a:t>
             </a:r>
             <a:endParaRPr lang="en-US" sz="1150" dirty="0"/>
           </a:p>

</xml_diff>

<commit_message>
The docs, deck and pictures did not show the point-cloud codec
doc-sync over the 29 commits since 8d44766, all tiers.

- Docs: the index points to middleware.md and ADR-0014, the experiment
  guide shows middleware and codec runs, and the ROS README lists the codec
  parameters and its tests.
- Diagrams: the overview, lifecycle and runtime-topology diagrams show raw
  or G-PCC coded clouds, where coding and decoding fall, and CODEC; the
  runtime topology names both near-RT RICs (ADR-0012).
- Deck: slides 5 and 6 show coding and decoding; slide 11 drops Draco for a
  G-PCC campaign. Hero: the client and edge cards and the footer name the
  codec.
- The doc-sync code-to-doc map gains the codec and middleware paths.
</commit_message>
<xml_diff>
--- a/docs/slides/mec-cast-architecture.pptx
+++ b/docs/slides/mec-cast-architecture.pptx
@@ -4763,7 +4763,7 @@
                 <a:ea typeface="Calibri" pitchFamily="34" charset="-122"/>
                 <a:cs typeface="Calibri" pitchFamily="34" charset="-120"/>
               </a:rPr>
-              <a:t>Draco compression as a measured variable</a:t>
+              <a:t>Campaign: G-PCC at 1 mm and 1 cm over 5G</a:t>
             </a:r>
             <a:endParaRPr lang="en-US" sz="1100" dirty="0"/>
           </a:p>
@@ -8449,7 +8449,7 @@
                 <a:ea typeface="Calibri" pitchFamily="34" charset="-122"/>
                 <a:cs typeface="Calibri" pitchFamily="34" charset="-120"/>
               </a:rPr>
-              <a:t>CloudWithTelemetry</a:t>
+              <a:t>raw, or G-PCC coded</a:t>
             </a:r>
             <a:endParaRPr lang="en-US" sz="1050" dirty="0"/>
           </a:p>
@@ -9084,6 +9084,27 @@
                 <a:cs typeface="Calibri" pitchFamily="34" charset="-120"/>
               </a:rPr>
               <a:t>The renderer is optional and off by default, so the one-way path stays byte-for-byte comparable with campaigns recorded before it existed.</a:t>
+            </a:r>
+            <a:endParaRPr lang="en-US" sz="1150" dirty="0"/>
+          </a:p>
+          <a:p>
+            <a:pPr marL="342900" indent="-342900">
+              <a:spcAft>
+                <a:spcPts val="500"/>
+              </a:spcAft>
+              <a:buSzPct val="100000"/>
+              <a:buChar char="•"/>
+            </a:pPr>
+            <a:r>
+              <a:rPr lang="en-US" sz="1150" dirty="0">
+                <a:solidFill>
+                  <a:srgbClr val="444C52"/>
+                </a:solidFill>
+                <a:latin typeface="Calibri" pitchFamily="34" charset="0"/>
+                <a:ea typeface="Calibri" pitchFamily="34" charset="-122"/>
+                <a:cs typeface="Calibri" pitchFamily="34" charset="-120"/>
+              </a:rPr>
+              <a:t>With codec=gpcc both legs travel G-PCC coded: encoding counts in the sender delay, decoding in processing (ADR-0014).</a:t>
             </a:r>
             <a:endParaRPr lang="en-US" sz="1150" dirty="0"/>
           </a:p>
@@ -9467,27 +9488,27 @@
                 <a:ea typeface="Calibri" pitchFamily="34" charset="-122"/>
                 <a:cs typeface="Calibri" pitchFamily="34" charset="-120"/>
               </a:rPr>
+              <a:t>decode, if G-PCC coded</a:t>
+            </a:r>
+            <a:endParaRPr lang="en-US" sz="1050" dirty="0"/>
+          </a:p>
+          <a:p>
+            <a:pPr indent="0" marL="0">
+              <a:lnSpc>
+                <a:spcPct val="108000"/>
+              </a:lnSpc>
+              <a:buNone/>
+            </a:pPr>
+            <a:r>
+              <a:rPr lang="en-US" sz="1050" dirty="0">
+                <a:solidFill>
+                  <a:srgbClr val="444C52"/>
+                </a:solidFill>
+                <a:latin typeface="Calibri" pitchFamily="34" charset="0"/>
+                <a:ea typeface="Calibri" pitchFamily="34" charset="-122"/>
+                <a:cs typeface="Calibri" pitchFamily="34" charset="-120"/>
+              </a:rPr>
               <a:t>centroid + voxel count</a:t>
-            </a:r>
-            <a:endParaRPr lang="en-US" sz="1050" dirty="0"/>
-          </a:p>
-          <a:p>
-            <a:pPr indent="0" marL="0">
-              <a:lnSpc>
-                <a:spcPct val="108000"/>
-              </a:lnSpc>
-              <a:buNone/>
-            </a:pPr>
-            <a:r>
-              <a:rPr lang="en-US" sz="1050" dirty="0">
-                <a:solidFill>
-                  <a:srgbClr val="444C52"/>
-                </a:solidFill>
-                <a:latin typeface="Calibri" pitchFamily="34" charset="0"/>
-                <a:ea typeface="Calibri" pitchFamily="34" charset="-122"/>
-                <a:cs typeface="Calibri" pitchFamily="34" charset="-120"/>
-              </a:rPr>
-              <a:t>deterministic</a:t>
             </a:r>
             <a:endParaRPr lang="en-US" sz="1050" dirty="0"/>
           </a:p>
@@ -10092,7 +10113,7 @@
                 <a:ea typeface="Calibri" pitchFamily="34" charset="-122"/>
                 <a:cs typeface="Calibri" pitchFamily="34" charset="-120"/>
               </a:rPr>
-              <a:t>With publish_result on, the voxel cloud already computed goes back to the UE on mec_cast/result — after record(), so the edge's own sample is never delayed for the renderer's benefit.</a:t>
+              <a:t>With publish_result on, the voxel cloud already computed goes back to the UE on mec_cast/result, or coded losslessly on mec_cast/result_gpcc — after record(), so the edge's own sample is never delayed for the renderer's benefit.</a:t>
             </a:r>
             <a:endParaRPr lang="en-US" sz="1150" dirty="0"/>
           </a:p>

</xml_diff>

<commit_message>
The diagrams and deck still showed the str0m SFU plan
- The runtime-topology diagram gains the media profile: the relay role
  (compose.relay.yml, usually on the edge host, :8090 tcp and udp) and the
  WebRTC client on a UE, run natively, with their admin, logging and PTP
  links.
- Slides 8-9 described a str0m SFU replacing the patched fork, which
  ADR-0015 did not do. They now show the system as built (sender, relay,
  receiver; the prebuilt fork; why the relay stays out of the
  measurement) and its three measuring points per frame.
- Slide 4 placed logging and the admin on the edge host; they run on
  infra.
- doc-sync: the slide table follows, and changed slides are now looked
  at, rendered through LibreOffice, not only checked geometrically.
  Synced to 0aa6f2f.
</commit_message>
<xml_diff>
--- a/docs/slides/mec-cast-architecture.pptx
+++ b/docs/slides/mec-cast-architecture.pptx
@@ -7304,7 +7304,7 @@
                 <a:ea typeface="Cambria" pitchFamily="34" charset="-122"/>
                 <a:cs typeface="Cambria" pitchFamily="34" charset="-120"/>
               </a:rPr>
-              <a:t>Edge services — logging and admin</a:t>
+              <a:t>Infra services — logging and admin</a:t>
             </a:r>
             <a:endParaRPr lang="en-US" sz="3200" dirty="0"/>
           </a:p>
@@ -7343,7 +7343,7 @@
                 <a:ea typeface="Calibri" pitchFamily="34" charset="-122"/>
                 <a:cs typeface="Calibri" pitchFamily="34" charset="-120"/>
               </a:rPr>
-              <a:t>Two first-party services on the edge host. Logging is where aggregated results land; admin is where runs are started and stopped.</a:t>
+              <a:t>Two first-party services on the infra host. Logging is where aggregated results land; admin is where runs are started and stopped.</a:t>
             </a:r>
             <a:endParaRPr lang="en-US" sz="1300" dirty="0"/>
           </a:p>
@@ -11349,7 +11349,7 @@
                 <a:ea typeface="Cambria" pitchFamily="34" charset="-122"/>
                 <a:cs typeface="Cambria" pitchFamily="34" charset="-120"/>
               </a:rPr>
-              <a:t>Profile B — WebRTC, current model</a:t>
+              <a:t>Profile B — WebRTC through a relay on the edge</a:t>
             </a:r>
             <a:endParaRPr lang="en-US" sz="3200" dirty="0"/>
           </a:p>
@@ -11388,7 +11388,7 @@
                 <a:ea typeface="Calibri" pitchFamily="34" charset="-122"/>
                 <a:cs typeface="Calibri" pitchFamily="34" charset="-120"/>
               </a:rPr>
-              <a:t>The platform's second transport profile: real-time media over WebRTC, measured with the same telemetry spine.</a:t>
+              <a:t>Video for teleoperation, from a sender on one UE to a receiver on another, measured where the 5G legs meet (ADR-0015).</a:t>
             </a:r>
             <a:endParaRPr lang="en-US" sz="1300" dirty="0"/>
           </a:p>
@@ -11403,7 +11403,7 @@
         <p:spPr>
           <a:xfrm>
             <a:off x="502920" y="1600200"/>
-            <a:ext cx="3429000" cy="1188720"/>
+            <a:ext cx="3108960" cy="1188720"/>
           </a:xfrm>
           <a:prstGeom prst="rect">
             <a:avLst/>
@@ -11428,7 +11428,7 @@
         <p:spPr>
           <a:xfrm>
             <a:off x="612648" y="1691640"/>
-            <a:ext cx="3209544" cy="274320"/>
+            <a:ext cx="2889504" cy="274320"/>
           </a:xfrm>
           <a:prstGeom prst="rect">
             <a:avLst/>
@@ -11452,7 +11452,7 @@
                 <a:ea typeface="Calibri" pitchFamily="34" charset="-122"/>
                 <a:cs typeface="Calibri" pitchFamily="34" charset="-120"/>
               </a:rPr>
-              <a:t>Native client</a:t>
+              <a:t>Sender — UE</a:t>
             </a:r>
             <a:endParaRPr lang="en-US" sz="1300" dirty="0"/>
           </a:p>
@@ -11467,7 +11467,7 @@
         <p:spPr>
           <a:xfrm>
             <a:off x="612648" y="1984248"/>
-            <a:ext cx="3209544" cy="713232"/>
+            <a:ext cx="2889504" cy="713232"/>
           </a:xfrm>
           <a:prstGeom prst="rect">
             <a:avLst/>
@@ -11494,7 +11494,7 @@
                 <a:ea typeface="Calibri" pitchFamily="34" charset="-122"/>
                 <a:cs typeface="Calibri" pitchFamily="34" charset="-120"/>
               </a:rPr>
-              <a:t>Node.js console app</a:t>
+              <a:t>Node app + C++ addon</a:t>
             </a:r>
             <a:endParaRPr lang="en-US" sz="1050" dirty="0"/>
           </a:p>
@@ -11514,10 +11514,30 @@
                 <a:ea typeface="Calibri" pitchFamily="34" charset="-122"/>
                 <a:cs typeface="Calibri" pitchFamily="34" charset="-120"/>
               </a:rPr>
-              <a:t>C++ N-API addon</a:t>
+              <a:t>synthetic or camera video</a:t>
             </a:r>
             <a:endParaRPr lang="en-US" sz="1050" dirty="0"/>
           </a:p>
+          <a:p>
+            <a:pPr indent="0" marL="0">
+              <a:lnSpc>
+                <a:spcPct val="108000"/>
+              </a:lnSpc>
+              <a:buNone/>
+            </a:pPr>
+            <a:r>
+              <a:rPr lang="en-US" sz="1050" dirty="0">
+                <a:solidFill>
+                  <a:srgbClr val="444C52"/>
+                </a:solidFill>
+                <a:latin typeface="Calibri" pitchFamily="34" charset="0"/>
+                <a:ea typeface="Calibri" pitchFamily="34" charset="-122"/>
+                <a:cs typeface="Calibri" pitchFamily="34" charset="-120"/>
+              </a:rPr>
+              <a:t>WHIP, over the 5G uplink</a:t>
+            </a:r>
+            <a:endParaRPr lang="en-US" sz="1050" dirty="0"/>
+          </a:p>
         </p:txBody>
       </p:sp>
       <p:sp>
@@ -11528,8 +11548,134 @@
         </p:nvSpPr>
         <p:spPr>
           <a:xfrm>
-            <a:off x="4389120" y="1600200"/>
-            <a:ext cx="3429000" cy="1188720"/>
+            <a:off x="4069080" y="1600200"/>
+            <a:ext cx="3931920" cy="1188720"/>
+          </a:xfrm>
+          <a:prstGeom prst="rect">
+            <a:avLst/>
+          </a:prstGeom>
+          <a:solidFill>
+            <a:srgbClr val="2B3136"/>
+          </a:solidFill>
+          <a:ln w="12700">
+            <a:solidFill>
+              <a:srgbClr val="2B3136"/>
+            </a:solidFill>
+            <a:prstDash val="solid"/>
+          </a:ln>
+        </p:spPr>
+      </p:sp>
+      <p:sp>
+        <p:nvSpPr>
+          <p:cNvPr id="8" name="Text 6"/>
+          <p:cNvSpPr/>
+          <p:nvPr/>
+        </p:nvSpPr>
+        <p:spPr>
+          <a:xfrm>
+            <a:off x="4178808" y="1691640"/>
+            <a:ext cx="3712464" cy="274320"/>
+          </a:xfrm>
+          <a:prstGeom prst="rect">
+            <a:avLst/>
+          </a:prstGeom>
+          <a:noFill/>
+          <a:ln/>
+        </p:spPr>
+        <p:txBody>
+          <a:bodyPr wrap="square" lIns="0" tIns="0" rIns="0" bIns="0" rtlCol="0" anchor="ctr"/>
+          <a:lstStyle/>
+          <a:p>
+            <a:pPr algn="l" indent="0" marL="0">
+              <a:buNone/>
+            </a:pPr>
+            <a:r>
+              <a:rPr lang="en-US" sz="1300" b="1" dirty="0">
+                <a:solidFill>
+                  <a:srgbClr val="FFFFFF"/>
+                </a:solidFill>
+                <a:latin typeface="Calibri" pitchFamily="34" charset="0"/>
+                <a:ea typeface="Calibri" pitchFamily="34" charset="-122"/>
+                <a:cs typeface="Calibri" pitchFamily="34" charset="-120"/>
+              </a:rPr>
+              <a:t>Relay on the MEC edge</a:t>
+            </a:r>
+            <a:endParaRPr lang="en-US" sz="1300" dirty="0"/>
+          </a:p>
+        </p:txBody>
+      </p:sp>
+      <p:sp>
+        <p:nvSpPr>
+          <p:cNvPr id="9" name="Text 7"/>
+          <p:cNvSpPr/>
+          <p:nvPr/>
+        </p:nvSpPr>
+        <p:spPr>
+          <a:xfrm>
+            <a:off x="4178808" y="1984248"/>
+            <a:ext cx="3712464" cy="713232"/>
+          </a:xfrm>
+          <a:prstGeom prst="rect">
+            <a:avLst/>
+          </a:prstGeom>
+          <a:noFill/>
+          <a:ln/>
+        </p:spPr>
+        <p:txBody>
+          <a:bodyPr wrap="square" lIns="0" tIns="0" rIns="0" bIns="0" rtlCol="0" anchor="t"/>
+          <a:lstStyle/>
+          <a:p>
+            <a:pPr indent="0" marL="0">
+              <a:lnSpc>
+                <a:spcPct val="108000"/>
+              </a:lnSpc>
+              <a:buNone/>
+            </a:pPr>
+            <a:r>
+              <a:rPr lang="en-US" sz="1050" dirty="0">
+                <a:solidFill>
+                  <a:srgbClr val="D5D8DA"/>
+                </a:solidFill>
+                <a:latin typeface="Calibri" pitchFamily="34" charset="0"/>
+                <a:ea typeface="Calibri" pitchFamily="34" charset="-122"/>
+                <a:cs typeface="Calibri" pitchFamily="34" charset="-120"/>
+              </a:rPr>
+              <a:t>str0m, unmodified: RTP mode, ICE-lite, one UDP port</a:t>
+            </a:r>
+            <a:endParaRPr lang="en-US" sz="1050" dirty="0"/>
+          </a:p>
+          <a:p>
+            <a:pPr indent="0" marL="0">
+              <a:lnSpc>
+                <a:spcPct val="108000"/>
+              </a:lnSpc>
+              <a:buNone/>
+            </a:pPr>
+            <a:r>
+              <a:rPr lang="en-US" sz="1050" dirty="0">
+                <a:solidFill>
+                  <a:srgbClr val="D5D8DA"/>
+                </a:solidFill>
+                <a:latin typeface="Calibri" pitchFamily="34" charset="0"/>
+                <a:ea typeface="Calibri" pitchFamily="34" charset="-122"/>
+                <a:cs typeface="Calibri" pitchFamily="34" charset="-120"/>
+              </a:rPr>
+              <a:t>forwards without decoding</a:t>
+            </a:r>
+            <a:endParaRPr lang="en-US" sz="1050" dirty="0"/>
+          </a:p>
+        </p:txBody>
+      </p:sp>
+      <p:sp>
+        <p:nvSpPr>
+          <p:cNvPr id="10" name="Shape 8"/>
+          <p:cNvSpPr/>
+          <p:nvPr/>
+        </p:nvSpPr>
+        <p:spPr>
+          <a:xfrm>
+            <a:off x="8458200" y="1600200"/>
+            <a:ext cx="3227832" cy="1188720"/>
           </a:xfrm>
           <a:prstGeom prst="rect">
             <a:avLst/>
@@ -11547,14 +11693,14 @@
       </p:sp>
       <p:sp>
         <p:nvSpPr>
-          <p:cNvPr id="8" name="Text 6"/>
-          <p:cNvSpPr/>
-          <p:nvPr/>
-        </p:nvSpPr>
-        <p:spPr>
-          <a:xfrm>
-            <a:off x="4498848" y="1691640"/>
-            <a:ext cx="3209544" cy="274320"/>
+          <p:cNvPr id="11" name="Text 9"/>
+          <p:cNvSpPr/>
+          <p:nvPr/>
+        </p:nvSpPr>
+        <p:spPr>
+          <a:xfrm>
+            <a:off x="8567928" y="1691640"/>
+            <a:ext cx="3008376" cy="274320"/>
           </a:xfrm>
           <a:prstGeom prst="rect">
             <a:avLst/>
@@ -11578,7 +11724,7 @@
                 <a:ea typeface="Calibri" pitchFamily="34" charset="-122"/>
                 <a:cs typeface="Calibri" pitchFamily="34" charset="-120"/>
               </a:rPr>
-              <a:t>Signaling server</a:t>
+              <a:t>Receiver — UE</a:t>
             </a:r>
             <a:endParaRPr lang="en-US" sz="1300" dirty="0"/>
           </a:p>
@@ -11586,14 +11732,14 @@
       </p:sp>
       <p:sp>
         <p:nvSpPr>
-          <p:cNvPr id="9" name="Text 7"/>
-          <p:cNvSpPr/>
-          <p:nvPr/>
-        </p:nvSpPr>
-        <p:spPr>
-          <a:xfrm>
-            <a:off x="4498848" y="1984248"/>
-            <a:ext cx="3209544" cy="713232"/>
+          <p:cNvPr id="12" name="Text 10"/>
+          <p:cNvSpPr/>
+          <p:nvPr/>
+        </p:nvSpPr>
+        <p:spPr>
+          <a:xfrm>
+            <a:off x="8567928" y="1984248"/>
+            <a:ext cx="3008376" cy="713232"/>
           </a:xfrm>
           <a:prstGeom prst="rect">
             <a:avLst/>
@@ -11620,7 +11766,7 @@
                 <a:ea typeface="Calibri" pitchFamily="34" charset="-122"/>
                 <a:cs typeface="Calibri" pitchFamily="34" charset="-120"/>
               </a:rPr>
-              <a:t>WebSocket, JSON</a:t>
+              <a:t>same client, role recv</a:t>
             </a:r>
             <a:endParaRPr lang="en-US" sz="1050" dirty="0"/>
           </a:p>
@@ -11640,22 +11786,90 @@
                 <a:ea typeface="Calibri" pitchFamily="34" charset="-122"/>
                 <a:cs typeface="Calibri" pitchFamily="34" charset="-120"/>
               </a:rPr>
-              <a:t>offer / answer / ICE</a:t>
+              <a:t>renders or headless</a:t>
             </a:r>
             <a:endParaRPr lang="en-US" sz="1050" dirty="0"/>
           </a:p>
-        </p:txBody>
-      </p:sp>
-      <p:sp>
-        <p:nvSpPr>
-          <p:cNvPr id="10" name="Shape 8"/>
-          <p:cNvSpPr/>
-          <p:nvPr/>
-        </p:nvSpPr>
-        <p:spPr>
-          <a:xfrm>
-            <a:off x="8275320" y="1600200"/>
-            <a:ext cx="3410712" cy="1188720"/>
+          <a:p>
+            <a:pPr indent="0" marL="0">
+              <a:lnSpc>
+                <a:spcPct val="108000"/>
+              </a:lnSpc>
+              <a:buNone/>
+            </a:pPr>
+            <a:r>
+              <a:rPr lang="en-US" sz="1050" dirty="0">
+                <a:solidFill>
+                  <a:srgbClr val="444C52"/>
+                </a:solidFill>
+                <a:latin typeface="Calibri" pitchFamily="34" charset="0"/>
+                <a:ea typeface="Calibri" pitchFamily="34" charset="-122"/>
+                <a:cs typeface="Calibri" pitchFamily="34" charset="-120"/>
+              </a:rPr>
+              <a:t>WHEP, over the 5G downlink</a:t>
+            </a:r>
+            <a:endParaRPr lang="en-US" sz="1050" dirty="0"/>
+          </a:p>
+        </p:txBody>
+      </p:sp>
+      <p:sp>
+        <p:nvSpPr>
+          <p:cNvPr id="13" name="Shape 11"/>
+          <p:cNvSpPr/>
+          <p:nvPr/>
+        </p:nvSpPr>
+        <p:spPr>
+          <a:xfrm>
+            <a:off x="3666744" y="2194560"/>
+            <a:ext cx="347472" cy="0"/>
+          </a:xfrm>
+          <a:prstGeom prst="line">
+            <a:avLst/>
+          </a:prstGeom>
+          <a:noFill/>
+          <a:ln w="15875">
+            <a:solidFill>
+              <a:srgbClr val="444C52"/>
+            </a:solidFill>
+            <a:prstDash val="solid"/>
+            <a:tailEnd type="triangle"/>
+          </a:ln>
+        </p:spPr>
+      </p:sp>
+      <p:sp>
+        <p:nvSpPr>
+          <p:cNvPr id="14" name="Shape 12"/>
+          <p:cNvSpPr/>
+          <p:nvPr/>
+        </p:nvSpPr>
+        <p:spPr>
+          <a:xfrm>
+            <a:off x="8055864" y="2194560"/>
+            <a:ext cx="347472" cy="0"/>
+          </a:xfrm>
+          <a:prstGeom prst="line">
+            <a:avLst/>
+          </a:prstGeom>
+          <a:noFill/>
+          <a:ln w="15875">
+            <a:solidFill>
+              <a:srgbClr val="444C52"/>
+            </a:solidFill>
+            <a:prstDash val="solid"/>
+            <a:tailEnd type="triangle"/>
+          </a:ln>
+        </p:spPr>
+      </p:sp>
+      <p:sp>
+        <p:nvSpPr>
+          <p:cNvPr id="15" name="Shape 13"/>
+          <p:cNvSpPr/>
+          <p:nvPr/>
+        </p:nvSpPr>
+        <p:spPr>
+          <a:xfrm>
+            <a:off x="502920" y="2999232"/>
+            <a:ext cx="5394960" cy="1783080"/>
           </a:xfrm>
           <a:prstGeom prst="rect">
             <a:avLst/>
@@ -11673,14 +11887,14 @@
       </p:sp>
       <p:sp>
         <p:nvSpPr>
-          <p:cNvPr id="11" name="Text 9"/>
-          <p:cNvSpPr/>
-          <p:nvPr/>
-        </p:nvSpPr>
-        <p:spPr>
-          <a:xfrm>
-            <a:off x="8385048" y="1691640"/>
-            <a:ext cx="3191256" cy="274320"/>
+          <p:cNvPr id="16" name="Text 14"/>
+          <p:cNvSpPr/>
+          <p:nvPr/>
+        </p:nvSpPr>
+        <p:spPr>
+          <a:xfrm>
+            <a:off x="612648" y="3090672"/>
+            <a:ext cx="5175504" cy="274320"/>
           </a:xfrm>
           <a:prstGeom prst="rect">
             <a:avLst/>
@@ -11704,7 +11918,7 @@
                 <a:ea typeface="Calibri" pitchFamily="34" charset="-122"/>
                 <a:cs typeface="Calibri" pitchFamily="34" charset="-120"/>
               </a:rPr>
-              <a:t>Peer client</a:t>
+              <a:t>A patched libwebrtc, prebuilt</a:t>
             </a:r>
             <a:endParaRPr lang="en-US" sz="1300" dirty="0"/>
           </a:p>
@@ -11712,14 +11926,14 @@
       </p:sp>
       <p:sp>
         <p:nvSpPr>
-          <p:cNvPr id="12" name="Text 10"/>
-          <p:cNvSpPr/>
-          <p:nvPr/>
-        </p:nvSpPr>
-        <p:spPr>
-          <a:xfrm>
-            <a:off x="8385048" y="1984248"/>
-            <a:ext cx="3191256" cy="713232"/>
+          <p:cNvPr id="17" name="Text 15"/>
+          <p:cNvSpPr/>
+          <p:nvPr/>
+        </p:nvSpPr>
+        <p:spPr>
+          <a:xfrm>
+            <a:off x="612648" y="3383280"/>
+            <a:ext cx="5175504" cy="1307592"/>
           </a:xfrm>
           <a:prstGeom prst="rect">
             <a:avLst/>
@@ -11738,97 +11952,89 @@
               <a:buNone/>
             </a:pPr>
             <a:r>
-              <a:rPr lang="en-US" sz="1050" dirty="0">
-                <a:solidFill>
-                  <a:srgbClr val="444C52"/>
-                </a:solidFill>
-                <a:latin typeface="Calibri" pitchFamily="34" charset="0"/>
-                <a:ea typeface="Calibri" pitchFamily="34" charset="-122"/>
-                <a:cs typeface="Calibri" pitchFamily="34" charset="-120"/>
-              </a:rPr>
-              <a:t>P2P after ICE</a:t>
-            </a:r>
-            <a:endParaRPr lang="en-US" sz="1050" dirty="0"/>
-          </a:p>
-          <a:p>
-            <a:pPr indent="0" marL="0">
-              <a:lnSpc>
-                <a:spcPct val="108000"/>
-              </a:lnSpc>
-              <a:buNone/>
-            </a:pPr>
-            <a:r>
-              <a:rPr lang="en-US" sz="1050" dirty="0">
-                <a:solidFill>
-                  <a:srgbClr val="444C52"/>
-                </a:solidFill>
-                <a:latin typeface="Calibri" pitchFamily="34" charset="0"/>
-                <a:ea typeface="Calibri" pitchFamily="34" charset="-122"/>
-                <a:cs typeface="Calibri" pitchFamily="34" charset="-120"/>
-              </a:rPr>
-              <a:t>renders + measures</a:t>
-            </a:r>
-            <a:endParaRPr lang="en-US" sz="1050" dirty="0"/>
-          </a:p>
-        </p:txBody>
-      </p:sp>
-      <p:sp>
-        <p:nvSpPr>
-          <p:cNvPr id="13" name="Shape 11"/>
-          <p:cNvSpPr/>
-          <p:nvPr/>
-        </p:nvSpPr>
-        <p:spPr>
-          <a:xfrm>
-            <a:off x="3986784" y="2194560"/>
-            <a:ext cx="347472" cy="0"/>
-          </a:xfrm>
-          <a:prstGeom prst="line">
-            <a:avLst/>
-          </a:prstGeom>
-          <a:noFill/>
-          <a:ln w="15875">
-            <a:solidFill>
-              <a:srgbClr val="444C52"/>
-            </a:solidFill>
-            <a:prstDash val="solid"/>
-            <a:tailEnd type="triangle"/>
-          </a:ln>
-        </p:spPr>
-      </p:sp>
-      <p:sp>
-        <p:nvSpPr>
-          <p:cNvPr id="14" name="Shape 12"/>
-          <p:cNvSpPr/>
-          <p:nvPr/>
-        </p:nvSpPr>
-        <p:spPr>
-          <a:xfrm>
-            <a:off x="7872984" y="2194560"/>
-            <a:ext cx="347472" cy="0"/>
-          </a:xfrm>
-          <a:prstGeom prst="line">
-            <a:avLst/>
-          </a:prstGeom>
-          <a:noFill/>
-          <a:ln w="15875">
-            <a:solidFill>
-              <a:srgbClr val="444C52"/>
-            </a:solidFill>
-            <a:prstDash val="solid"/>
-            <a:tailEnd type="triangle"/>
-          </a:ln>
-        </p:spPr>
-      </p:sp>
-      <p:sp>
-        <p:nvSpPr>
-          <p:cNvPr id="15" name="Shape 13"/>
-          <p:cNvSpPr/>
-          <p:nvPr/>
-        </p:nvSpPr>
-        <p:spPr>
-          <a:xfrm>
-            <a:off x="502920" y="2999232"/>
+              <a:rPr lang="en-US" sz="1100" dirty="0">
+                <a:solidFill>
+                  <a:srgbClr val="444C52"/>
+                </a:solidFill>
+                <a:latin typeface="Calibri" pitchFamily="34" charset="0"/>
+                <a:ea typeface="Calibri" pitchFamily="34" charset="-122"/>
+                <a:cs typeface="Calibri" pitchFamily="34" charset="-120"/>
+              </a:rPr>
+              <a:t>The fork stamps every packet with a 16-byte RTP header</a:t>
+            </a:r>
+            <a:endParaRPr lang="en-US" sz="1100" dirty="0"/>
+          </a:p>
+          <a:p>
+            <a:pPr indent="0" marL="0">
+              <a:lnSpc>
+                <a:spcPct val="108000"/>
+              </a:lnSpc>
+              <a:buNone/>
+            </a:pPr>
+            <a:r>
+              <a:rPr lang="en-US" sz="1100" dirty="0">
+                <a:solidFill>
+                  <a:srgbClr val="444C52"/>
+                </a:solidFill>
+                <a:latin typeface="Calibri" pitchFamily="34" charset="0"/>
+                <a:ea typeface="Calibri" pitchFamily="34" charset="-122"/>
+                <a:cs typeface="Calibri" pitchFamily="34" charset="-120"/>
+              </a:rPr>
+              <a:t>extension, capture_ns and send_ns, and makes every frame a</a:t>
+            </a:r>
+            <a:endParaRPr lang="en-US" sz="1100" dirty="0"/>
+          </a:p>
+          <a:p>
+            <a:pPr indent="0" marL="0">
+              <a:lnSpc>
+                <a:spcPct val="108000"/>
+              </a:lnSpc>
+              <a:buNone/>
+            </a:pPr>
+            <a:r>
+              <a:rPr lang="en-US" sz="1100" dirty="0">
+                <a:solidFill>
+                  <a:srgbClr val="444C52"/>
+                </a:solidFill>
+                <a:latin typeface="Calibri" pitchFamily="34" charset="0"/>
+                <a:ea typeface="Calibri" pitchFamily="34" charset="-122"/>
+                <a:cs typeface="Calibri" pitchFamily="34" charset="-120"/>
+              </a:rPr>
+              <a:t>timing frame. Its release workflow builds linux-x64 and</a:t>
+            </a:r>
+            <a:endParaRPr lang="en-US" sz="1100" dirty="0"/>
+          </a:p>
+          <a:p>
+            <a:pPr indent="0" marL="0">
+              <a:lnSpc>
+                <a:spcPct val="108000"/>
+              </a:lnSpc>
+              <a:buNone/>
+            </a:pPr>
+            <a:r>
+              <a:rPr lang="en-US" sz="1100" dirty="0">
+                <a:solidFill>
+                  <a:srgbClr val="444C52"/>
+                </a:solidFill>
+                <a:latin typeface="Calibri" pitchFamily="34" charset="0"/>
+                <a:ea typeface="Calibri" pitchFamily="34" charset="-122"/>
+                <a:cs typeface="Calibri" pitchFamily="34" charset="-120"/>
+              </a:rPr>
+              <a:t>macos-arm64; make fetch-libwebrtc downloads the pinned one.</a:t>
+            </a:r>
+            <a:endParaRPr lang="en-US" sz="1100" dirty="0"/>
+          </a:p>
+        </p:txBody>
+      </p:sp>
+      <p:sp>
+        <p:nvSpPr>
+          <p:cNvPr id="18" name="Shape 16"/>
+          <p:cNvSpPr/>
+          <p:nvPr/>
+        </p:nvSpPr>
+        <p:spPr>
+          <a:xfrm>
+            <a:off x="6291072" y="2999232"/>
             <a:ext cx="5394960" cy="1783080"/>
           </a:xfrm>
           <a:prstGeom prst="rect">
@@ -11847,172 +12053,6 @@
       </p:sp>
       <p:sp>
         <p:nvSpPr>
-          <p:cNvPr id="16" name="Text 14"/>
-          <p:cNvSpPr/>
-          <p:nvPr/>
-        </p:nvSpPr>
-        <p:spPr>
-          <a:xfrm>
-            <a:off x="612648" y="3090672"/>
-            <a:ext cx="5175504" cy="274320"/>
-          </a:xfrm>
-          <a:prstGeom prst="rect">
-            <a:avLst/>
-          </a:prstGeom>
-          <a:noFill/>
-          <a:ln/>
-        </p:spPr>
-        <p:txBody>
-          <a:bodyPr wrap="square" lIns="0" tIns="0" rIns="0" bIns="0" rtlCol="0" anchor="ctr"/>
-          <a:lstStyle/>
-          <a:p>
-            <a:pPr algn="l" indent="0" marL="0">
-              <a:buNone/>
-            </a:pPr>
-            <a:r>
-              <a:rPr lang="en-US" sz="1300" b="1" dirty="0">
-                <a:solidFill>
-                  <a:srgbClr val="1A1A1A"/>
-                </a:solidFill>
-                <a:latin typeface="Calibri" pitchFamily="34" charset="0"/>
-                <a:ea typeface="Calibri" pitchFamily="34" charset="-122"/>
-                <a:cs typeface="Calibri" pitchFamily="34" charset="-120"/>
-              </a:rPr>
-              <a:t>How the timing gets across</a:t>
-            </a:r>
-            <a:endParaRPr lang="en-US" sz="1300" dirty="0"/>
-          </a:p>
-        </p:txBody>
-      </p:sp>
-      <p:sp>
-        <p:nvSpPr>
-          <p:cNvPr id="17" name="Text 15"/>
-          <p:cNvSpPr/>
-          <p:nvPr/>
-        </p:nvSpPr>
-        <p:spPr>
-          <a:xfrm>
-            <a:off x="612648" y="3383280"/>
-            <a:ext cx="5175504" cy="1307592"/>
-          </a:xfrm>
-          <a:prstGeom prst="rect">
-            <a:avLst/>
-          </a:prstGeom>
-          <a:noFill/>
-          <a:ln/>
-        </p:spPr>
-        <p:txBody>
-          <a:bodyPr wrap="square" lIns="0" tIns="0" rIns="0" bIns="0" rtlCol="0" anchor="t"/>
-          <a:lstStyle/>
-          <a:p>
-            <a:pPr indent="0" marL="0">
-              <a:lnSpc>
-                <a:spcPct val="108000"/>
-              </a:lnSpc>
-              <a:buNone/>
-            </a:pPr>
-            <a:r>
-              <a:rPr lang="en-US" sz="1100" dirty="0">
-                <a:solidFill>
-                  <a:srgbClr val="444C52"/>
-                </a:solidFill>
-                <a:latin typeface="Calibri" pitchFamily="34" charset="0"/>
-                <a:ea typeface="Calibri" pitchFamily="34" charset="-122"/>
-                <a:cs typeface="Calibri" pitchFamily="34" charset="-120"/>
-              </a:rPr>
-              <a:t>A patched libwebrtc fork adds a custom 16-byte RTP header</a:t>
-            </a:r>
-            <a:endParaRPr lang="en-US" sz="1100" dirty="0"/>
-          </a:p>
-          <a:p>
-            <a:pPr indent="0" marL="0">
-              <a:lnSpc>
-                <a:spcPct val="108000"/>
-              </a:lnSpc>
-              <a:buNone/>
-            </a:pPr>
-            <a:r>
-              <a:rPr lang="en-US" sz="1100" dirty="0">
-                <a:solidFill>
-                  <a:srgbClr val="444C52"/>
-                </a:solidFill>
-                <a:latin typeface="Calibri" pitchFamily="34" charset="0"/>
-                <a:ea typeface="Calibri" pitchFamily="34" charset="-122"/>
-                <a:cs typeface="Calibri" pitchFamily="34" charset="-120"/>
-              </a:rPr>
-              <a:t>extension carrying capture_ns and send_ns, and forces every</a:t>
-            </a:r>
-            <a:endParaRPr lang="en-US" sz="1100" dirty="0"/>
-          </a:p>
-          <a:p>
-            <a:pPr indent="0" marL="0">
-              <a:lnSpc>
-                <a:spcPct val="108000"/>
-              </a:lnSpc>
-              <a:buNone/>
-            </a:pPr>
-            <a:r>
-              <a:rPr lang="en-US" sz="1100" dirty="0">
-                <a:solidFill>
-                  <a:srgbClr val="444C52"/>
-                </a:solidFill>
-                <a:latin typeface="Calibri" pitchFamily="34" charset="0"/>
-                <a:ea typeface="Calibri" pitchFamily="34" charset="-122"/>
-                <a:cs typeface="Calibri" pitchFamily="34" charset="-120"/>
-              </a:rPr>
-              <a:t>frame to be a timing frame — upstream only samples</a:t>
-            </a:r>
-            <a:endParaRPr lang="en-US" sz="1100" dirty="0"/>
-          </a:p>
-          <a:p>
-            <a:pPr indent="0" marL="0">
-              <a:lnSpc>
-                <a:spcPct val="108000"/>
-              </a:lnSpc>
-              <a:buNone/>
-            </a:pPr>
-            <a:r>
-              <a:rPr lang="en-US" sz="1100" dirty="0">
-                <a:solidFill>
-                  <a:srgbClr val="444C52"/>
-                </a:solidFill>
-                <a:latin typeface="Calibri" pitchFamily="34" charset="0"/>
-                <a:ea typeface="Calibri" pitchFamily="34" charset="-122"/>
-                <a:cs typeface="Calibri" pitchFamily="34" charset="-120"/>
-              </a:rPr>
-              <a:t>periodically, which is useless per-frame.</a:t>
-            </a:r>
-            <a:endParaRPr lang="en-US" sz="1100" dirty="0"/>
-          </a:p>
-        </p:txBody>
-      </p:sp>
-      <p:sp>
-        <p:nvSpPr>
-          <p:cNvPr id="18" name="Shape 16"/>
-          <p:cNvSpPr/>
-          <p:nvPr/>
-        </p:nvSpPr>
-        <p:spPr>
-          <a:xfrm>
-            <a:off x="6291072" y="2999232"/>
-            <a:ext cx="5394960" cy="1783080"/>
-          </a:xfrm>
-          <a:prstGeom prst="rect">
-            <a:avLst/>
-          </a:prstGeom>
-          <a:solidFill>
-            <a:srgbClr val="F1F2F3"/>
-          </a:solidFill>
-          <a:ln w="12700">
-            <a:solidFill>
-              <a:srgbClr val="B9BDC0"/>
-            </a:solidFill>
-            <a:prstDash val="solid"/>
-          </a:ln>
-        </p:spPr>
-      </p:sp>
-      <p:sp>
-        <p:nvSpPr>
           <p:cNvPr id="19" name="Text 17"/>
           <p:cNvSpPr/>
           <p:nvPr/>
@@ -12044,7 +12084,7 @@
                 <a:ea typeface="Calibri" pitchFamily="34" charset="-122"/>
                 <a:cs typeface="Calibri" pitchFamily="34" charset="-120"/>
               </a:rPr>
-              <a:t>Attached to the shared spine</a:t>
+              <a:t>The relay stays out of the measurement</a:t>
             </a:r>
             <a:endParaRPr lang="en-US" sz="1300" dirty="0"/>
           </a:p>
@@ -12086,7 +12126,7 @@
                 <a:ea typeface="Calibri" pitchFamily="34" charset="-122"/>
                 <a:cs typeface="Calibri" pitchFamily="34" charset="-120"/>
               </a:rPr>
-              <a:t>The addon links the telemetry crate over a C ABI and records</a:t>
+              <a:t>It writes the sender's extension back unchanged, so the</a:t>
             </a:r>
             <a:endParaRPr lang="en-US" sz="1100" dirty="0"/>
           </a:p>
@@ -12106,7 +12146,7 @@
                 <a:ea typeface="Calibri" pitchFamily="34" charset="-122"/>
                 <a:cs typeface="Calibri" pitchFamily="34" charset="-120"/>
               </a:rPr>
-              <a:t>one sample per rendered frame, so media runs land in the same</a:t>
+              <a:t>receiver measures as it would with no relay, and passes</a:t>
             </a:r>
             <a:endParaRPr lang="en-US" sz="1100" dirty="0"/>
           </a:p>
@@ -12126,7 +12166,7 @@
                 <a:ea typeface="Calibri" pitchFamily="34" charset="-122"/>
                 <a:cs typeface="Calibri" pitchFamily="34" charset="-120"/>
               </a:rPr>
-              <a:t>CSV schema and the same database as the point-cloud profile.</a:t>
+              <a:t>keyframe requests back to the sender. Clients dial out to it;</a:t>
             </a:r>
             <a:endParaRPr lang="en-US" sz="1100" dirty="0"/>
           </a:p>
@@ -12146,7 +12186,7 @@
                 <a:ea typeface="Calibri" pitchFamily="34" charset="-122"/>
                 <a:cs typeface="Calibri" pitchFamily="34" charset="-120"/>
               </a:rPr>
-              <a:t>One RUN_ID joins both.</a:t>
+              <a:t>it forwards a frame in tens of microseconds.</a:t>
             </a:r>
             <a:endParaRPr lang="en-US" sz="1100" dirty="0"/>
           </a:p>
@@ -12188,7 +12228,7 @@
                 <a:ea typeface="Calibri" pitchFamily="34" charset="-122"/>
                 <a:cs typeface="Calibri" pitchFamily="34" charset="-120"/>
               </a:rPr>
-              <a:t>The cost of this approach: the fork is a ~20 GB source tree that takes hours to build, and the measurement points are only as good as the places the patch can reach. Encode duration, for example, arrives quantised to whole milliseconds in a system that otherwise measures in nanoseconds.</a:t>
+              <a:t>Limits: no arm64 Linux clients (Chromium ships no clang for that host), no camera on macOS yet, and the relay advertises one address, RELAY_PUBLIC_IP. Peer-to-peer calls through the signaling server stay, as the baseline a relayed call is compared with.</a:t>
             </a:r>
             <a:endParaRPr lang="en-US" sz="1150" dirty="0"/>
           </a:p>
@@ -12259,7 +12299,7 @@
                 <a:ea typeface="Cambria" pitchFamily="34" charset="-122"/>
                 <a:cs typeface="Cambria" pitchFamily="34" charset="-120"/>
               </a:rPr>
-              <a:t>Profile B — planned: str0m with an SFU</a:t>
+              <a:t>Profile B — three measuring points per frame</a:t>
             </a:r>
             <a:endParaRPr lang="en-US" sz="3200" dirty="0"/>
           </a:p>
@@ -12298,7 +12338,7 @@
                 <a:ea typeface="Calibri" pitchFamily="34" charset="-122"/>
                 <a:cs typeface="Calibri" pitchFamily="34" charset="-120"/>
               </a:rPr>
-              <a:t>Replacing the patched fork with a sans-IO library, so precise timestamps fall out of the architecture instead of a patch.</a:t>
+              <a:t>Joined on the frame's RTP timestamp, so one video frame splits into its uplink, forwarding, downlink and playout.</a:t>
             </a:r>
             <a:endParaRPr lang="en-US" sz="1300" dirty="0"/>
           </a:p>
@@ -12313,7 +12353,7 @@
         <p:spPr>
           <a:xfrm>
             <a:off x="502920" y="1600200"/>
-            <a:ext cx="3108960" cy="1188720"/>
+            <a:ext cx="3108960" cy="1371600"/>
           </a:xfrm>
           <a:prstGeom prst="rect">
             <a:avLst/>
@@ -12362,7 +12402,7 @@
                 <a:ea typeface="Calibri" pitchFamily="34" charset="-122"/>
                 <a:cs typeface="Calibri" pitchFamily="34" charset="-120"/>
               </a:rPr>
-              <a:t>Publisher</a:t>
+              <a:t>Sender</a:t>
             </a:r>
             <a:endParaRPr lang="en-US" sz="1300" dirty="0"/>
           </a:p>
@@ -12377,7 +12417,7 @@
         <p:spPr>
           <a:xfrm>
             <a:off x="612648" y="1984248"/>
-            <a:ext cx="2889504" cy="713232"/>
+            <a:ext cx="2889504" cy="896112"/>
           </a:xfrm>
           <a:prstGeom prst="rect">
             <a:avLst/>
@@ -12404,10 +12444,50 @@
                 <a:ea typeface="Calibri" pitchFamily="34" charset="-122"/>
                 <a:cs typeface="Calibri" pitchFamily="34" charset="-120"/>
               </a:rPr>
-              <a:t>encodes and sends</a:t>
+              <a:t>capture_ns, send_ns</a:t>
             </a:r>
             <a:endParaRPr lang="en-US" sz="1050" dirty="0"/>
           </a:p>
+          <a:p>
+            <a:pPr indent="0" marL="0">
+              <a:lnSpc>
+                <a:spcPct val="108000"/>
+              </a:lnSpc>
+              <a:buNone/>
+            </a:pPr>
+            <a:r>
+              <a:rPr lang="en-US" sz="1050" dirty="0">
+                <a:solidFill>
+                  <a:srgbClr val="444C52"/>
+                </a:solidFill>
+                <a:latin typeface="Calibri" pitchFamily="34" charset="0"/>
+                <a:ea typeface="Calibri" pitchFamily="34" charset="-122"/>
+                <a:cs typeface="Calibri" pitchFamily="34" charset="-120"/>
+              </a:rPr>
+              <a:t>in the RTP extension</a:t>
+            </a:r>
+            <a:endParaRPr lang="en-US" sz="1050" dirty="0"/>
+          </a:p>
+          <a:p>
+            <a:pPr indent="0" marL="0">
+              <a:lnSpc>
+                <a:spcPct val="108000"/>
+              </a:lnSpc>
+              <a:buNone/>
+            </a:pPr>
+            <a:r>
+              <a:rPr lang="en-US" sz="1050" dirty="0">
+                <a:solidFill>
+                  <a:srgbClr val="444C52"/>
+                </a:solidFill>
+                <a:latin typeface="Calibri" pitchFamily="34" charset="0"/>
+                <a:ea typeface="Calibri" pitchFamily="34" charset="-122"/>
+                <a:cs typeface="Calibri" pitchFamily="34" charset="-120"/>
+              </a:rPr>
+              <a:t>WebRTC stats: bitrate, estimate</a:t>
+            </a:r>
+            <a:endParaRPr lang="en-US" sz="1050" dirty="0"/>
+          </a:p>
         </p:txBody>
       </p:sp>
       <p:sp>
@@ -12419,7 +12499,7 @@
         <p:spPr>
           <a:xfrm>
             <a:off x="4069080" y="1600200"/>
-            <a:ext cx="3931920" cy="1188720"/>
+            <a:ext cx="3931920" cy="1371600"/>
           </a:xfrm>
           <a:prstGeom prst="rect">
             <a:avLst/>
@@ -12468,7 +12548,7 @@
                 <a:ea typeface="Calibri" pitchFamily="34" charset="-122"/>
                 <a:cs typeface="Calibri" pitchFamily="34" charset="-120"/>
               </a:rPr>
-              <a:t>SFU on the MEC edge</a:t>
+              <a:t>Relay — site 3</a:t>
             </a:r>
             <a:endParaRPr lang="en-US" sz="1300" dirty="0"/>
           </a:p>
@@ -12483,7 +12563,7 @@
         <p:spPr>
           <a:xfrm>
             <a:off x="4178808" y="1984248"/>
-            <a:ext cx="3712464" cy="713232"/>
+            <a:ext cx="3712464" cy="896112"/>
           </a:xfrm>
           <a:prstGeom prst="rect">
             <a:avLst/>
@@ -12510,7 +12590,7 @@
                 <a:ea typeface="Calibri" pitchFamily="34" charset="-122"/>
                 <a:cs typeface="Calibri" pitchFamily="34" charset="-120"/>
               </a:rPr>
-              <a:t>str0m state machine, owns its UDP socket</a:t>
+              <a:t>network_ns: the uplink alone</a:t>
             </a:r>
             <a:endParaRPr lang="en-US" sz="1050" dirty="0"/>
           </a:p>
@@ -12530,10 +12610,30 @@
                 <a:ea typeface="Calibri" pitchFamily="34" charset="-122"/>
                 <a:cs typeface="Calibri" pitchFamily="34" charset="-120"/>
               </a:rPr>
-              <a:t>selective forwarding — one upstream, many down</a:t>
+              <a:t>processing_ns: its forwarding</a:t>
             </a:r>
             <a:endParaRPr lang="en-US" sz="1050" dirty="0"/>
           </a:p>
+          <a:p>
+            <a:pPr indent="0" marL="0">
+              <a:lnSpc>
+                <a:spcPct val="108000"/>
+              </a:lnSpc>
+              <a:buNone/>
+            </a:pPr>
+            <a:r>
+              <a:rPr lang="en-US" sz="1050" dirty="0">
+                <a:solidFill>
+                  <a:srgbClr val="D5D8DA"/>
+                </a:solidFill>
+                <a:latin typeface="Calibri" pitchFamily="34" charset="0"/>
+                <a:ea typeface="Calibri" pitchFamily="34" charset="-122"/>
+                <a:cs typeface="Calibri" pitchFamily="34" charset="-120"/>
+              </a:rPr>
+              <a:t>jitter, loss and RTT of both legs</a:t>
+            </a:r>
+            <a:endParaRPr lang="en-US" sz="1050" dirty="0"/>
+          </a:p>
         </p:txBody>
       </p:sp>
       <p:sp>
@@ -12545,7 +12645,7 @@
         <p:spPr>
           <a:xfrm>
             <a:off x="8458200" y="1600200"/>
-            <a:ext cx="3227832" cy="1188720"/>
+            <a:ext cx="3227832" cy="1371600"/>
           </a:xfrm>
           <a:prstGeom prst="rect">
             <a:avLst/>
@@ -12594,7 +12694,7 @@
                 <a:ea typeface="Calibri" pitchFamily="34" charset="-122"/>
                 <a:cs typeface="Calibri" pitchFamily="34" charset="-120"/>
               </a:rPr>
-              <a:t>Subscribers</a:t>
+              <a:t>Receiver — site 4</a:t>
             </a:r>
             <a:endParaRPr lang="en-US" sz="1300" dirty="0"/>
           </a:p>
@@ -12609,7 +12709,7 @@
         <p:spPr>
           <a:xfrm>
             <a:off x="8567928" y="1984248"/>
-            <a:ext cx="3008376" cy="713232"/>
+            <a:ext cx="3008376" cy="896112"/>
           </a:xfrm>
           <a:prstGeom prst="rect">
             <a:avLst/>
@@ -12636,7 +12736,7 @@
                 <a:ea typeface="Calibri" pitchFamily="34" charset="-122"/>
                 <a:cs typeface="Calibri" pitchFamily="34" charset="-120"/>
               </a:rPr>
-              <a:t>many receivers</a:t>
+              <a:t>e2e_ns: glass-to-glass</a:t>
             </a:r>
             <a:endParaRPr lang="en-US" sz="1050" dirty="0"/>
           </a:p>
@@ -12656,10 +12756,30 @@
                 <a:ea typeface="Calibri" pitchFamily="34" charset="-122"/>
                 <a:cs typeface="Calibri" pitchFamily="34" charset="-120"/>
               </a:rPr>
-              <a:t>no mesh, no re-encode</a:t>
+              <a:t>jitter buffer, decode, render</a:t>
             </a:r>
             <a:endParaRPr lang="en-US" sz="1050" dirty="0"/>
           </a:p>
+          <a:p>
+            <a:pPr indent="0" marL="0">
+              <a:lnSpc>
+                <a:spcPct val="108000"/>
+              </a:lnSpc>
+              <a:buNone/>
+            </a:pPr>
+            <a:r>
+              <a:rPr lang="en-US" sz="1050" dirty="0">
+                <a:solidFill>
+                  <a:srgbClr val="444C52"/>
+                </a:solidFill>
+                <a:latin typeface="Calibri" pitchFamily="34" charset="0"/>
+                <a:ea typeface="Calibri" pitchFamily="34" charset="-122"/>
+                <a:cs typeface="Calibri" pitchFamily="34" charset="-120"/>
+              </a:rPr>
+              <a:t>freezes, NACKs, PLIs</a:t>
+            </a:r>
+            <a:endParaRPr lang="en-US" sz="1050" dirty="0"/>
+          </a:p>
         </p:txBody>
       </p:sp>
       <p:sp>
@@ -12670,7 +12790,7 @@
         </p:nvSpPr>
         <p:spPr>
           <a:xfrm>
-            <a:off x="3666744" y="2194560"/>
+            <a:off x="3666744" y="2286000"/>
             <a:ext cx="347472" cy="0"/>
           </a:xfrm>
           <a:prstGeom prst="line">
@@ -12694,7 +12814,7 @@
         </p:nvSpPr>
         <p:spPr>
           <a:xfrm>
-            <a:off x="8055864" y="2194560"/>
+            <a:off x="8055864" y="2286000"/>
             <a:ext cx="347472" cy="0"/>
           </a:xfrm>
           <a:prstGeom prst="line">
@@ -12718,8 +12838,8 @@
         </p:nvSpPr>
         <p:spPr>
           <a:xfrm>
-            <a:off x="502920" y="2999232"/>
-            <a:ext cx="5394960" cy="1920240"/>
+            <a:off x="502920" y="3182112"/>
+            <a:ext cx="5394960" cy="1371600"/>
           </a:xfrm>
           <a:prstGeom prst="rect">
             <a:avLst/>
@@ -12747,7 +12867,7 @@
                 <a:ea typeface="Calibri" pitchFamily="34" charset="-122"/>
                 <a:cs typeface="Calibri" pitchFamily="34" charset="-120"/>
               </a:rPr>
-              <a:t>Sans-IO: the application owns the socket and the event loop.</a:t>
+              <a:t>Per frame: the platform's CSV schema, at the relay and the receiver.</a:t>
             </a:r>
             <a:endParaRPr lang="en-US" sz="1150" dirty="0"/>
           </a:p>
@@ -12768,7 +12888,7 @@
                 <a:ea typeface="Calibri" pitchFamily="34" charset="-122"/>
                 <a:cs typeface="Calibri" pitchFamily="34" charset="-120"/>
               </a:rPr>
-              <a:t>send_ns is stamped at the actual socket write, recv_ns at the socket read.</a:t>
+              <a:t>Per stream, every second: WebRTC's own statistics in webrtc.csv at all three, and in the logging service.</a:t>
             </a:r>
             <a:endParaRPr lang="en-US" sz="1150" dirty="0"/>
           </a:p>
@@ -12789,7 +12909,7 @@
                 <a:ea typeface="Calibri" pitchFamily="34" charset="-122"/>
                 <a:cs typeface="Calibri" pitchFamily="34" charset="-120"/>
               </a:rPr>
-              <a:t>No forked media stack to maintain, and no 20 GB build.</a:t>
+              <a:t>tools/media_join.py splits each frame into its legs and attaches the streams' state.</a:t>
             </a:r>
             <a:endParaRPr lang="en-US" sz="1150" dirty="0"/>
           </a:p>
@@ -12803,8 +12923,8 @@
         </p:nvSpPr>
         <p:spPr>
           <a:xfrm>
-            <a:off x="6291072" y="2999232"/>
-            <a:ext cx="5394960" cy="1920240"/>
+            <a:off x="6291072" y="3182112"/>
+            <a:ext cx="5394960" cy="1371600"/>
           </a:xfrm>
           <a:prstGeom prst="rect">
             <a:avLst/>
@@ -12832,7 +12952,7 @@
                 <a:ea typeface="Calibri" pitchFamily="34" charset="-122"/>
                 <a:cs typeface="Calibri" pitchFamily="34" charset="-120"/>
               </a:rPr>
-              <a:t>An SFU scales to many viewers — the natural shape for teleoperation and multi-operator monitoring.</a:t>
+              <a:t>Under the admin, a run with profile media recruits the relay, a sender and a receiver; the RAN sources join too.</a:t>
             </a:r>
             <a:endParaRPr lang="en-US" sz="1150" dirty="0"/>
           </a:p>
@@ -12853,7 +12973,7 @@
                 <a:ea typeface="Calibri" pitchFamily="34" charset="-122"/>
                 <a:cs typeface="Calibri" pitchFamily="34" charset="-120"/>
               </a:rPr>
-              <a:t>Feeds the identical recorder, so media and point-cloud runs stay directly comparable.</a:t>
+              <a:t>The run's params set the stream and the video's size and rate.</a:t>
             </a:r>
             <a:endParaRPr lang="en-US" sz="1150" dirty="0"/>
           </a:p>
@@ -12874,7 +12994,7 @@
                 <a:ea typeface="Calibri" pitchFamily="34" charset="-122"/>
                 <a:cs typeface="Calibri" pitchFamily="34" charset="-120"/>
               </a:rPr>
-              <a:t>The SFU is a MEC server component; the library fork stays vendored separately.</a:t>
+              <a:t>run.json records the stream, the video and the libwebrtc release.</a:t>
             </a:r>
             <a:endParaRPr lang="en-US" sz="1150" dirty="0"/>
           </a:p>
@@ -12888,8 +13008,8 @@
         </p:nvSpPr>
         <p:spPr>
           <a:xfrm>
-            <a:off x="502920" y="5120640"/>
-            <a:ext cx="11183112" cy="1188720"/>
+            <a:off x="502920" y="4754880"/>
+            <a:ext cx="11183112" cy="1097280"/>
           </a:xfrm>
           <a:prstGeom prst="rect">
             <a:avLst/>
@@ -12916,7 +13036,7 @@
                 <a:ea typeface="Calibri" pitchFamily="34" charset="-122"/>
                 <a:cs typeface="Calibri" pitchFamily="34" charset="-120"/>
               </a:rPr>
-              <a:t>Open design point: the 64-byte envelope exceeds the 16-byte limit of the one-byte RTP extension format, so either the two-byte format is used or the extension carries the timestamps only, with the rest inferred per session. The CSV and snapshot contract is unaffected either way.</a:t>
+              <a:t>Every cross-host figure needs PTP on both hosts. WebRTC's clock is not CLOCK_MONOTONIC on macOS, so the fork converts against WebRTC's own clock; a Mac rarely has PTP, the lab's Linux hosts and edge do.</a:t>
             </a:r>
             <a:endParaRPr lang="en-US" sz="1150" dirty="0"/>
           </a:p>

</xml_diff>